<commit_message>
Add presentation attribution and repository link
</commit_message>
<xml_diff>
--- a/output/presentation/PSUB-Technical-Runbook.pptx
+++ b/output/presentation/PSUB-Technical-Runbook.pptx
@@ -3782,6 +3782,58 @@
                 <a:latin typeface="Aptos"/>
               </a:rPr>
               <a:t>A build operator can prepare the machine, run PSUB, verify artifacts, and retain evidence.</a:t>
+            </a:r>
+          </a:p>
+        </p:txBody>
+      </p:sp>
+      <p:sp>
+        <p:nvSpPr>
+          <p:cNvPr id="19" name="TextBox 18"/>
+          <p:cNvSpPr txBox="1"/>
+          <p:nvPr/>
+        </p:nvSpPr>
+        <p:spPr>
+          <a:xfrm>
+            <a:off x="566928" y="3895344"/>
+            <a:ext cx="5212080" cy="493776"/>
+          </a:xfrm>
+          <a:prstGeom prst="rect">
+            <a:avLst/>
+          </a:prstGeom>
+          <a:noFill/>
+        </p:spPr>
+        <p:txBody>
+          <a:bodyPr wrap="square" anchor="t">
+            <a:spAutoFit/>
+          </a:bodyPr>
+          <a:lstStyle/>
+          <a:p>
+            <a:pPr algn="l"/>
+            <a:r>
+              <a:rPr sz="1300" b="1">
+                <a:solidFill>
+                  <a:srgbClr val="26323F"/>
+                </a:solidFill>
+                <a:latin typeface="Aptos"/>
+              </a:rPr>
+              <a:t>Built by Patrik Karlsson</a:t>
+            </a:r>
+          </a:p>
+          <a:p>
+            <a:pPr algn="l">
+              <a:spcBef>
+                <a:spcPts val="200"/>
+              </a:spcBef>
+            </a:pPr>
+            <a:r>
+              <a:rPr sz="1200">
+                <a:solidFill>
+                  <a:srgbClr val="2F6FAE"/>
+                </a:solidFill>
+                <a:latin typeface="Aptos"/>
+                <a:hlinkClick r:id="rId2"/>
+              </a:rPr>
+              <a:t>Repository: github.com/patrikkarlsson72/psub</a:t>
             </a:r>
           </a:p>
         </p:txBody>

</xml_diff>

<commit_message>
Finalize technical runbook presentation
</commit_message>
<xml_diff>
--- a/output/presentation/PSUB-Technical-Runbook.pptx
+++ b/output/presentation/PSUB-Technical-Runbook.pptx
@@ -3794,7 +3794,7 @@
         </p:nvSpPr>
         <p:spPr>
           <a:xfrm>
-            <a:off x="566928" y="3895344"/>
+            <a:off x="548640" y="5783580"/>
             <a:ext cx="5212080" cy="493776"/>
           </a:xfrm>
           <a:prstGeom prst="rect">
@@ -3810,7 +3810,7 @@
           <a:p>
             <a:pPr algn="l"/>
             <a:r>
-              <a:rPr sz="1300" b="1">
+              <a:rPr sz="1300" b="1" dirty="0">
                 <a:solidFill>
                   <a:srgbClr val="26323F"/>
                 </a:solidFill>
@@ -3826,15 +3826,32 @@
               </a:spcBef>
             </a:pPr>
             <a:r>
-              <a:rPr sz="1200">
+              <a:rPr sz="1200" dirty="0">
                 <a:solidFill>
                   <a:srgbClr val="2F6FAE"/>
                 </a:solidFill>
                 <a:latin typeface="Aptos"/>
                 <a:hlinkClick r:id="rId2"/>
               </a:rPr>
-              <a:t>Repository: github.com/patrikkarlsson72/psub</a:t>
-            </a:r>
+              <a:t>Repository: github.com/patrikkarlsson72/</a:t>
+            </a:r>
+            <a:r>
+              <a:rPr sz="1200" dirty="0" err="1">
+                <a:solidFill>
+                  <a:srgbClr val="2F6FAE"/>
+                </a:solidFill>
+                <a:latin typeface="Aptos"/>
+                <a:hlinkClick r:id="rId2"/>
+              </a:rPr>
+              <a:t>psub</a:t>
+            </a:r>
+            <a:endParaRPr sz="1200" dirty="0">
+              <a:solidFill>
+                <a:srgbClr val="2F6FAE"/>
+              </a:solidFill>
+              <a:latin typeface="Aptos"/>
+              <a:hlinkClick r:id="rId2"/>
+            </a:endParaRPr>
           </a:p>
         </p:txBody>
       </p:sp>

</xml_diff>